<commit_message>
Teachers' Day: cards and notes straight (no tilt), bigger opening and closing notes, sharper Nick photo
Co-Authored-By: Claude Opus 5.5 <noreply@anthropic.com>
Claude-Session: https://claude.ai/code/session_014HGzAbxBh54nuyJHG7tse8
</commit_message>
<xml_diff>
--- a/templates/posts/october/05-10-2026-mon-ig-teachers-day.pptx
+++ b/templates/posts/october/05-10-2026-mon-ig-teachers-day.pptx
@@ -4756,9 +4756,9 @@
           <p:nvPr/>
         </p:nvSpPr>
         <p:spPr>
-          <a:xfrm rot="21480000">
-            <a:off x="2000250" y="3810000"/>
-            <a:ext cx="6286500" cy="4476750"/>
+          <a:xfrm>
+            <a:off x="1619250" y="3143250"/>
+            <a:ext cx="7048500" cy="5905500"/>
           </a:xfrm>
           <a:prstGeom prst="rect">
             <a:avLst/>
@@ -4807,7 +4807,7 @@
         </p:nvSpPr>
         <p:spPr>
           <a:xfrm rot="19920000">
-            <a:off x="1857375" y="3657600"/>
+            <a:off x="1476375" y="2990850"/>
             <a:ext cx="1428750" cy="419100"/>
           </a:xfrm>
           <a:prstGeom prst="rect">
@@ -4853,7 +4853,7 @@
         </p:nvSpPr>
         <p:spPr>
           <a:xfrm rot="1680000">
-            <a:off x="7000875" y="3657600"/>
+            <a:off x="7381875" y="2990850"/>
             <a:ext cx="1428750" cy="419100"/>
           </a:xfrm>
           <a:prstGeom prst="rect">
@@ -4899,8 +4899,8 @@
         </p:nvSpPr>
         <p:spPr>
           <a:xfrm>
-            <a:off x="2286000" y="4476750"/>
-            <a:ext cx="5715000" cy="4191659"/>
+            <a:off x="2000250" y="3810000"/>
+            <a:ext cx="6286500" cy="4362343"/>
           </a:xfrm>
           <a:prstGeom prst="rect">
             <a:avLst/>
@@ -4919,7 +4919,7 @@
               </a:lnSpc>
             </a:pPr>
             <a:r>
-              <a:rPr sz="4800" b="1" i="0">
+              <a:rPr sz="5000" b="1" i="0">
                 <a:solidFill>
                   <a:srgbClr val="22371F"/>
                 </a:solidFill>
@@ -4939,9 +4939,9 @@
         <p:grpSpPr>
           <a:xfrm rot="360000">
             <a:off x="0" y="0"/>
-            <a:ext cx="7739062" cy="8858250"/>
+            <a:ext cx="8186736" cy="10096500"/>
             <a:chOff x="0" y="0"/>
-            <a:chExt cx="7739062" cy="8858250"/>
+            <a:chExt cx="8186736" cy="10096500"/>
           </a:xfrm>
         </p:grpSpPr>
         <p:sp>
@@ -4952,8 +4952,8 @@
           </p:nvSpPr>
           <p:spPr>
             <a:xfrm>
-              <a:off x="6738937" y="8715375"/>
-              <a:ext cx="1000125" cy="142875"/>
+              <a:off x="7053262" y="9934575"/>
+              <a:ext cx="1133474" cy="161925"/>
             </a:xfrm>
             <a:prstGeom prst="roundRect">
               <a:avLst/>
@@ -5004,8 +5004,8 @@
           </p:nvSpPr>
           <p:spPr>
             <a:xfrm>
-              <a:off x="7310437" y="7829550"/>
-              <a:ext cx="200025" cy="914400"/>
+              <a:off x="7700962" y="8930640"/>
+              <a:ext cx="226695" cy="1036320"/>
             </a:xfrm>
             <a:prstGeom prst="roundRect">
               <a:avLst/>
@@ -5050,8 +5050,8 @@
           </p:nvSpPr>
           <p:spPr>
             <a:xfrm>
-              <a:off x="6838950" y="8315325"/>
-              <a:ext cx="714375" cy="71437"/>
+              <a:off x="7166610" y="9481185"/>
+              <a:ext cx="809625" cy="80962"/>
             </a:xfrm>
             <a:prstGeom prst="rect">
               <a:avLst/>
@@ -5094,8 +5094,8 @@
           </p:nvSpPr>
           <p:spPr>
             <a:xfrm rot="20520000">
-              <a:off x="6953250" y="7500937"/>
-              <a:ext cx="228600" cy="714375"/>
+              <a:off x="7296150" y="8558212"/>
+              <a:ext cx="259080" cy="809625"/>
             </a:xfrm>
             <a:prstGeom prst="roundRect">
               <a:avLst/>
@@ -5140,8 +5140,8 @@
           </p:nvSpPr>
           <p:spPr>
             <a:xfrm rot="20520000">
-              <a:off x="6853237" y="7372350"/>
-              <a:ext cx="285750" cy="142875"/>
+              <a:off x="7182802" y="8412480"/>
+              <a:ext cx="323850" cy="161925"/>
             </a:xfrm>
             <a:prstGeom prst="roundRect">
               <a:avLst/>
@@ -5186,8 +5186,8 @@
           </p:nvSpPr>
           <p:spPr>
             <a:xfrm>
-              <a:off x="7267575" y="7972425"/>
-              <a:ext cx="200025" cy="200025"/>
+              <a:off x="7652385" y="9092565"/>
+              <a:ext cx="226695" cy="226695"/>
             </a:xfrm>
             <a:prstGeom prst="ellipse">
               <a:avLst/>
@@ -5232,9 +5232,9 @@
         <p:grpSpPr>
           <a:xfrm rot="21240000">
             <a:off x="0" y="0"/>
-            <a:ext cx="3810000" cy="9124950"/>
+            <a:ext cx="3476625" cy="10191750"/>
             <a:chOff x="0" y="0"/>
-            <a:chExt cx="3810000" cy="9124950"/>
+            <a:chExt cx="3476625" cy="10191750"/>
           </a:xfrm>
         </p:grpSpPr>
         <p:sp>
@@ -5245,8 +5245,8 @@
           </p:nvSpPr>
           <p:spPr>
             <a:xfrm>
-              <a:off x="3105150" y="8031480"/>
-              <a:ext cx="76200" cy="826770"/>
+              <a:off x="2724150" y="9020175"/>
+              <a:ext cx="76200" cy="885825"/>
             </a:xfrm>
             <a:prstGeom prst="rect">
               <a:avLst/>
@@ -5289,8 +5289,8 @@
           </p:nvSpPr>
           <p:spPr>
             <a:xfrm rot="8700000">
-              <a:off x="2609850" y="7844790"/>
-              <a:ext cx="533400" cy="266700"/>
+              <a:off x="2190750" y="8820150"/>
+              <a:ext cx="571500" cy="285750"/>
             </a:xfrm>
             <a:prstGeom prst="ellipse">
               <a:avLst/>
@@ -5335,8 +5335,8 @@
           </p:nvSpPr>
           <p:spPr>
             <a:xfrm rot="2100000">
-              <a:off x="3143250" y="7844790"/>
-              <a:ext cx="533400" cy="266700"/>
+              <a:off x="2762250" y="8820150"/>
+              <a:ext cx="571500" cy="285750"/>
             </a:xfrm>
             <a:prstGeom prst="ellipse">
               <a:avLst/>
@@ -5381,8 +5381,8 @@
           </p:nvSpPr>
           <p:spPr>
             <a:xfrm>
-              <a:off x="2476500" y="8724900"/>
-              <a:ext cx="1333500" cy="400050"/>
+              <a:off x="2047875" y="9763125"/>
+              <a:ext cx="1428750" cy="428625"/>
             </a:xfrm>
             <a:prstGeom prst="ellipse">
               <a:avLst/>
@@ -5433,8 +5433,8 @@
           </p:nvSpPr>
           <p:spPr>
             <a:xfrm>
-              <a:off x="3043237" y="8880304"/>
-              <a:ext cx="35901" cy="35901"/>
+              <a:off x="2655093" y="9929629"/>
+              <a:ext cx="38466" cy="38466"/>
             </a:xfrm>
             <a:prstGeom prst="ellipse">
               <a:avLst/>
@@ -5477,8 +5477,8 @@
           </p:nvSpPr>
           <p:spPr>
             <a:xfrm>
-              <a:off x="3207360" y="8880304"/>
-              <a:ext cx="35901" cy="35901"/>
+              <a:off x="2830939" y="9929629"/>
+              <a:ext cx="38466" cy="38466"/>
             </a:xfrm>
             <a:prstGeom prst="ellipse">
               <a:avLst/>
@@ -5521,8 +5521,8 @@
           </p:nvSpPr>
           <p:spPr>
             <a:xfrm rot="10800000">
-              <a:off x="3086832" y="8908512"/>
-              <a:ext cx="112834" cy="82061"/>
+              <a:off x="2701802" y="9959852"/>
+              <a:ext cx="120894" cy="87923"/>
             </a:xfrm>
             <a:prstGeom prst="blockArc">
               <a:avLst>
@@ -5619,7 +5619,7 @@
           <p:nvPr/>
         </p:nvGrpSpPr>
         <p:grpSpPr>
-          <a:xfrm rot="180000">
+          <a:xfrm>
             <a:off x="0" y="0"/>
             <a:ext cx="9429750" cy="12334875"/>
             <a:chOff x="0" y="0"/>
@@ -6669,7 +6669,7 @@
           <p:nvPr/>
         </p:nvGrpSpPr>
         <p:grpSpPr>
-          <a:xfrm rot="180000">
+          <a:xfrm>
             <a:off x="0" y="0"/>
             <a:ext cx="9429750" cy="12334875"/>
             <a:chOff x="0" y="0"/>
@@ -6730,7 +6730,7 @@
         </p:sp>
         <p:pic>
           <p:nvPicPr>
-            <p:cNvPr id="4" name="Picture 3" descr="9001695925251202517.jpg"/>
+            <p:cNvPr id="4" name="Picture 3" descr="737939244691707000.jpg"/>
             <p:cNvPicPr>
               <a:picLocks noChangeAspect="1"/>
             </p:cNvPicPr>
@@ -7850,7 +7850,7 @@
           <p:nvPr/>
         </p:nvGrpSpPr>
         <p:grpSpPr>
-          <a:xfrm rot="180000">
+          <a:xfrm>
             <a:off x="0" y="0"/>
             <a:ext cx="9429750" cy="12334875"/>
             <a:chOff x="0" y="0"/>
@@ -9160,7 +9160,7 @@
           <p:nvPr/>
         </p:nvGrpSpPr>
         <p:grpSpPr>
-          <a:xfrm rot="180000">
+          <a:xfrm>
             <a:off x="0" y="0"/>
             <a:ext cx="9429750" cy="12334875"/>
             <a:chOff x="0" y="0"/>
@@ -9897,7 +9897,7 @@
           <p:nvPr/>
         </p:nvGrpSpPr>
         <p:grpSpPr>
-          <a:xfrm rot="180000">
+          <a:xfrm>
             <a:off x="0" y="0"/>
             <a:ext cx="9429750" cy="12334875"/>
             <a:chOff x="0" y="0"/>
@@ -9958,7 +9958,7 @@
         </p:sp>
         <p:pic>
           <p:nvPicPr>
-            <p:cNvPr id="4" name="Picture 3" descr="4466978079890479619.jpg"/>
+            <p:cNvPr id="4" name="Picture 3" descr="1477269886006864837.jpg"/>
             <p:cNvPicPr>
               <a:picLocks noChangeAspect="1"/>
             </p:cNvPicPr>
@@ -10942,7 +10942,7 @@
           <p:nvPr/>
         </p:nvGrpSpPr>
         <p:grpSpPr>
-          <a:xfrm rot="180000">
+          <a:xfrm>
             <a:off x="0" y="0"/>
             <a:ext cx="9429750" cy="12334875"/>
             <a:chOff x="0" y="0"/>
@@ -12250,9 +12250,9 @@
           <p:nvPr/>
         </p:nvSpPr>
         <p:spPr>
-          <a:xfrm rot="120000">
-            <a:off x="2000250" y="4286250"/>
-            <a:ext cx="6286500" cy="4286250"/>
+          <a:xfrm>
+            <a:off x="1619250" y="3429000"/>
+            <a:ext cx="7048500" cy="5524500"/>
           </a:xfrm>
           <a:prstGeom prst="rect">
             <a:avLst/>
@@ -12301,7 +12301,7 @@
         </p:nvSpPr>
         <p:spPr>
           <a:xfrm rot="19920000">
-            <a:off x="1857375" y="4133850"/>
+            <a:off x="1476375" y="3276600"/>
             <a:ext cx="1428750" cy="419100"/>
           </a:xfrm>
           <a:prstGeom prst="rect">
@@ -12347,7 +12347,7 @@
         </p:nvSpPr>
         <p:spPr>
           <a:xfrm rot="1680000">
-            <a:off x="7000875" y="4133850"/>
+            <a:off x="7381875" y="3276600"/>
             <a:ext cx="1428750" cy="419100"/>
           </a:xfrm>
           <a:prstGeom prst="rect">
@@ -12393,8 +12393,8 @@
         </p:nvSpPr>
         <p:spPr>
           <a:xfrm>
-            <a:off x="2286000" y="5048250"/>
-            <a:ext cx="5715000" cy="4191659"/>
+            <a:off x="2000250" y="4095750"/>
+            <a:ext cx="6286500" cy="4362343"/>
           </a:xfrm>
           <a:prstGeom prst="rect">
             <a:avLst/>
@@ -12413,7 +12413,7 @@
               </a:lnSpc>
             </a:pPr>
             <a:r>
-              <a:rPr sz="4800" b="1" i="0">
+              <a:rPr sz="5000" b="1" i="0">
                 <a:solidFill>
                   <a:srgbClr val="22371F"/>
                 </a:solidFill>
@@ -12433,9 +12433,9 @@
         <p:grpSpPr>
           <a:xfrm rot="21120000">
             <a:off x="0" y="0"/>
-            <a:ext cx="3589020" cy="9972675"/>
+            <a:ext cx="3303270" cy="10639425"/>
             <a:chOff x="0" y="0"/>
-            <a:chExt cx="3589020" cy="9972675"/>
+            <a:chExt cx="3303270" cy="10639425"/>
           </a:xfrm>
         </p:grpSpPr>
         <p:sp>
@@ -12446,7 +12446,7 @@
           </p:nvSpPr>
           <p:spPr>
             <a:xfrm>
-              <a:off x="3114675" y="8858250"/>
+              <a:off x="2828925" y="9525000"/>
               <a:ext cx="57150" cy="1114425"/>
             </a:xfrm>
             <a:prstGeom prst="rect">
@@ -12490,7 +12490,7 @@
           </p:nvSpPr>
           <p:spPr>
             <a:xfrm rot="19800000">
-              <a:off x="3162300" y="9415462"/>
+              <a:off x="2876550" y="10082212"/>
               <a:ext cx="385762" cy="171450"/>
             </a:xfrm>
             <a:prstGeom prst="ellipse">
@@ -12536,7 +12536,7 @@
           </p:nvSpPr>
           <p:spPr>
             <a:xfrm>
-              <a:off x="3228975" y="8738235"/>
+              <a:off x="2943225" y="9404985"/>
               <a:ext cx="360045" cy="240030"/>
             </a:xfrm>
             <a:prstGeom prst="ellipse">
@@ -12582,7 +12582,7 @@
           </p:nvSpPr>
           <p:spPr>
             <a:xfrm rot="3600000">
-              <a:off x="3096101" y="8968379"/>
+              <a:off x="2810351" y="9635129"/>
               <a:ext cx="360045" cy="240030"/>
             </a:xfrm>
             <a:prstGeom prst="ellipse">
@@ -12628,7 +12628,7 @@
           </p:nvSpPr>
           <p:spPr>
             <a:xfrm rot="7200000">
-              <a:off x="2830353" y="8968379"/>
+              <a:off x="2544603" y="9635129"/>
               <a:ext cx="360045" cy="240030"/>
             </a:xfrm>
             <a:prstGeom prst="ellipse">
@@ -12674,7 +12674,7 @@
           </p:nvSpPr>
           <p:spPr>
             <a:xfrm rot="10800000">
-              <a:off x="2697480" y="8738235"/>
+              <a:off x="2411730" y="9404985"/>
               <a:ext cx="360045" cy="240030"/>
             </a:xfrm>
             <a:prstGeom prst="ellipse">
@@ -12720,7 +12720,7 @@
           </p:nvSpPr>
           <p:spPr>
             <a:xfrm rot="14400000">
-              <a:off x="2830353" y="8508090"/>
+              <a:off x="2544603" y="9174840"/>
               <a:ext cx="360045" cy="240030"/>
             </a:xfrm>
             <a:prstGeom prst="ellipse">
@@ -12766,7 +12766,7 @@
           </p:nvSpPr>
           <p:spPr>
             <a:xfrm rot="18000000">
-              <a:off x="3096101" y="8508090"/>
+              <a:off x="2810351" y="9174840"/>
               <a:ext cx="360045" cy="240030"/>
             </a:xfrm>
             <a:prstGeom prst="ellipse">
@@ -12812,7 +12812,7 @@
           </p:nvSpPr>
           <p:spPr>
             <a:xfrm>
-              <a:off x="2980372" y="8695372"/>
+              <a:off x="2694622" y="9362122"/>
               <a:ext cx="325755" cy="325755"/>
             </a:xfrm>
             <a:prstGeom prst="ellipse">
@@ -12860,9 +12860,9 @@
         <p:grpSpPr>
           <a:xfrm rot="20880000">
             <a:off x="0" y="0"/>
-            <a:ext cx="7905750" cy="9328785"/>
+            <a:ext cx="8239125" cy="10015537"/>
             <a:chOff x="0" y="0"/>
-            <a:chExt cx="7905750" cy="9328785"/>
+            <a:chExt cx="8239125" cy="10015537"/>
           </a:xfrm>
         </p:grpSpPr>
         <p:sp>
@@ -12873,8 +12873,8 @@
           </p:nvSpPr>
           <p:spPr>
             <a:xfrm>
-              <a:off x="6358890" y="8970340"/>
-              <a:ext cx="226695" cy="145618"/>
+              <a:off x="6581775" y="9631489"/>
+              <a:ext cx="242887" cy="156019"/>
             </a:xfrm>
             <a:prstGeom prst="arc">
               <a:avLst/>
@@ -12917,8 +12917,8 @@
           </p:nvSpPr>
           <p:spPr>
             <a:xfrm rot="10800000">
-              <a:off x="6145530" y="8981541"/>
-              <a:ext cx="226695" cy="145618"/>
+              <a:off x="6353175" y="9643491"/>
+              <a:ext cx="242887" cy="156019"/>
             </a:xfrm>
             <a:prstGeom prst="arc">
               <a:avLst/>
@@ -12961,8 +12961,8 @@
           </p:nvSpPr>
           <p:spPr>
             <a:xfrm>
-              <a:off x="5932170" y="8970340"/>
-              <a:ext cx="226695" cy="145618"/>
+              <a:off x="6124575" y="9631489"/>
+              <a:ext cx="242887" cy="156019"/>
             </a:xfrm>
             <a:prstGeom prst="arc">
               <a:avLst/>
@@ -13005,8 +13005,8 @@
           </p:nvSpPr>
           <p:spPr>
             <a:xfrm>
-              <a:off x="6572250" y="8768715"/>
-              <a:ext cx="1333500" cy="560070"/>
+              <a:off x="6810375" y="9415462"/>
+              <a:ext cx="1428750" cy="600075"/>
             </a:xfrm>
             <a:prstGeom prst="roundRect">
               <a:avLst>
@@ -13059,8 +13059,8 @@
           </p:nvSpPr>
           <p:spPr>
             <a:xfrm>
-              <a:off x="7280823" y="8999531"/>
-              <a:ext cx="42429" cy="42429"/>
+              <a:off x="7569560" y="9662766"/>
+              <a:ext cx="45460" cy="45460"/>
             </a:xfrm>
             <a:prstGeom prst="ellipse">
               <a:avLst/>
@@ -13103,8 +13103,8 @@
           </p:nvSpPr>
           <p:spPr>
             <a:xfrm>
-              <a:off x="7474787" y="8999531"/>
-              <a:ext cx="42429" cy="42429"/>
+              <a:off x="7777378" y="9662766"/>
+              <a:ext cx="45460" cy="45460"/>
             </a:xfrm>
             <a:prstGeom prst="ellipse">
               <a:avLst/>
@@ -13147,8 +13147,8 @@
           </p:nvSpPr>
           <p:spPr>
             <a:xfrm rot="10800000">
-              <a:off x="7332345" y="9032869"/>
-              <a:ext cx="133350" cy="96981"/>
+              <a:off x="7624762" y="9698484"/>
+              <a:ext cx="142874" cy="103909"/>
             </a:xfrm>
             <a:prstGeom prst="blockArc">
               <a:avLst>
@@ -13245,7 +13245,7 @@
           <p:nvPr/>
         </p:nvGrpSpPr>
         <p:grpSpPr>
-          <a:xfrm rot="180000">
+          <a:xfrm>
             <a:off x="0" y="0"/>
             <a:ext cx="9429750" cy="12334875"/>
             <a:chOff x="0" y="0"/>
@@ -14295,7 +14295,7 @@
           <p:nvPr/>
         </p:nvGrpSpPr>
         <p:grpSpPr>
-          <a:xfrm rot="180000">
+          <a:xfrm>
             <a:off x="0" y="0"/>
             <a:ext cx="9429750" cy="12334875"/>
             <a:chOff x="0" y="0"/>
@@ -14356,7 +14356,7 @@
         </p:sp>
         <p:pic>
           <p:nvPicPr>
-            <p:cNvPr id="4" name="Picture 3" descr="6711507890228017999.jpg"/>
+            <p:cNvPr id="4" name="Picture 3" descr="1823346550101891004.jpg"/>
             <p:cNvPicPr>
               <a:picLocks noChangeAspect="1"/>
             </p:cNvPicPr>
@@ -15386,7 +15386,7 @@
           <p:nvPr/>
         </p:nvGrpSpPr>
         <p:grpSpPr>
-          <a:xfrm rot="180000">
+          <a:xfrm>
             <a:off x="0" y="0"/>
             <a:ext cx="9429750" cy="12334875"/>
             <a:chOff x="0" y="0"/>
@@ -15447,7 +15447,7 @@
         </p:sp>
         <p:pic>
           <p:nvPicPr>
-            <p:cNvPr id="4" name="Picture 3" descr="6242569719062395373.jpg"/>
+            <p:cNvPr id="4" name="Picture 3" descr="460503049612907722.jpg"/>
             <p:cNvPicPr>
               <a:picLocks noChangeAspect="1"/>
             </p:cNvPicPr>
@@ -16389,7 +16389,7 @@
           <p:nvPr/>
         </p:nvGrpSpPr>
         <p:grpSpPr>
-          <a:xfrm rot="180000">
+          <a:xfrm>
             <a:off x="0" y="0"/>
             <a:ext cx="9429750" cy="12334875"/>
             <a:chOff x="0" y="0"/>
@@ -16450,7 +16450,7 @@
         </p:sp>
         <p:pic>
           <p:nvPicPr>
-            <p:cNvPr id="4" name="Picture 3" descr="7580433875254582571.jpg"/>
+            <p:cNvPr id="4" name="Picture 3" descr="155160722596274885.jpg"/>
             <p:cNvPicPr>
               <a:picLocks noChangeAspect="1"/>
             </p:cNvPicPr>
@@ -17346,7 +17346,7 @@
           <p:nvPr/>
         </p:nvGrpSpPr>
         <p:grpSpPr>
-          <a:xfrm rot="180000">
+          <a:xfrm>
             <a:off x="0" y="0"/>
             <a:ext cx="9429750" cy="12334875"/>
             <a:chOff x="0" y="0"/>
@@ -18396,7 +18396,7 @@
           <p:nvPr/>
         </p:nvGrpSpPr>
         <p:grpSpPr>
-          <a:xfrm rot="180000">
+          <a:xfrm>
             <a:off x="0" y="0"/>
             <a:ext cx="9429750" cy="12334875"/>
             <a:chOff x="0" y="0"/>
@@ -19536,7 +19536,7 @@
           <p:nvPr/>
         </p:nvGrpSpPr>
         <p:grpSpPr>
-          <a:xfrm rot="180000">
+          <a:xfrm>
             <a:off x="0" y="0"/>
             <a:ext cx="9429750" cy="12334875"/>
             <a:chOff x="0" y="0"/>
@@ -20846,7 +20846,7 @@
           <p:nvPr/>
         </p:nvGrpSpPr>
         <p:grpSpPr>
-          <a:xfrm rot="180000">
+          <a:xfrm>
             <a:off x="0" y="0"/>
             <a:ext cx="9429750" cy="12334875"/>
             <a:chOff x="0" y="0"/>

</xml_diff>